<commit_message>
lots of thesis figures
</commit_message>
<xml_diff>
--- a/Writing/thesis/results/results_figures.pptx
+++ b/Writing/thesis/results/results_figures.pptx
@@ -5,7 +5,7 @@
     <p:sldMasterId id="2147483684" r:id="rId1"/>
   </p:sldMasterIdLst>
   <p:notesMasterIdLst>
-    <p:notesMasterId r:id="rId8"/>
+    <p:notesMasterId r:id="rId12"/>
   </p:notesMasterIdLst>
   <p:sldIdLst>
     <p:sldId id="259" r:id="rId2"/>
@@ -14,6 +14,10 @@
     <p:sldId id="263" r:id="rId5"/>
     <p:sldId id="265" r:id="rId6"/>
     <p:sldId id="264" r:id="rId7"/>
+    <p:sldId id="266" r:id="rId8"/>
+    <p:sldId id="273" r:id="rId9"/>
+    <p:sldId id="274" r:id="rId10"/>
+    <p:sldId id="275" r:id="rId11"/>
   </p:sldIdLst>
   <p:sldSz cx="12179300" cy="12733338"/>
   <p:notesSz cx="6858000" cy="9144000"/>
@@ -202,7 +206,7 @@
           <a:p>
             <a:fld id="{51561201-B54B-9546-B2B5-5B57BF2ECE4E}" type="datetimeFigureOut">
               <a:rPr lang="en-US" smtClean="0"/>
-              <a:t>3/3/26</a:t>
+              <a:t>4/5/26</a:t>
             </a:fld>
             <a:endParaRPr lang="en-US"/>
           </a:p>
@@ -1315,6 +1319,474 @@
 </p:notes>
 </file>
 
+<file path=ppt/notesSlides/notesSlide6.xml><?xml version="1.0" encoding="utf-8"?>
+<p:notes xmlns:a="http://schemas.openxmlformats.org/drawingml/2006/main" xmlns:r="http://schemas.openxmlformats.org/officeDocument/2006/relationships" xmlns:p="http://schemas.openxmlformats.org/presentationml/2006/main">
+  <p:cSld>
+    <p:spTree>
+      <p:nvGrpSpPr>
+        <p:cNvPr id="1" name=""/>
+        <p:cNvGrpSpPr/>
+        <p:nvPr/>
+      </p:nvGrpSpPr>
+      <p:grpSpPr>
+        <a:xfrm>
+          <a:off x="0" y="0"/>
+          <a:ext cx="0" cy="0"/>
+          <a:chOff x="0" y="0"/>
+          <a:chExt cx="0" cy="0"/>
+        </a:xfrm>
+      </p:grpSpPr>
+      <p:sp>
+        <p:nvSpPr>
+          <p:cNvPr id="2" name="Slide Image Placeholder 1"/>
+          <p:cNvSpPr>
+            <a:spLocks noGrp="1" noRot="1" noChangeAspect="1"/>
+          </p:cNvSpPr>
+          <p:nvPr>
+            <p:ph type="sldImg"/>
+          </p:nvPr>
+        </p:nvSpPr>
+        <p:spPr/>
+      </p:sp>
+      <p:sp>
+        <p:nvSpPr>
+          <p:cNvPr id="3" name="Notes Placeholder 2"/>
+          <p:cNvSpPr>
+            <a:spLocks noGrp="1"/>
+          </p:cNvSpPr>
+          <p:nvPr>
+            <p:ph type="body" idx="1"/>
+          </p:nvPr>
+        </p:nvSpPr>
+        <p:spPr/>
+        <p:txBody>
+          <a:bodyPr/>
+          <a:lstStyle/>
+          <a:p>
+            <a:r>
+              <a:rPr lang="en-US" dirty="0"/>
+              <a:t>Traces</a:t>
+            </a:r>
+          </a:p>
+          <a:p>
+            <a:r>
+              <a:rPr lang="en-US" dirty="0"/>
+              <a:t>Rep cell</a:t>
+            </a:r>
+          </a:p>
+          <a:p>
+            <a:r>
+              <a:rPr lang="en-US" dirty="0"/>
+              <a:t>PPR and CV</a:t>
+            </a:r>
+          </a:p>
+        </p:txBody>
+      </p:sp>
+      <p:sp>
+        <p:nvSpPr>
+          <p:cNvPr id="4" name="Slide Number Placeholder 3"/>
+          <p:cNvSpPr>
+            <a:spLocks noGrp="1"/>
+          </p:cNvSpPr>
+          <p:nvPr>
+            <p:ph type="sldNum" sz="quarter" idx="5"/>
+          </p:nvPr>
+        </p:nvSpPr>
+        <p:spPr/>
+        <p:txBody>
+          <a:bodyPr/>
+          <a:lstStyle/>
+          <a:p>
+            <a:fld id="{F708F06A-076A-AB49-9E02-15A3C27D2EF7}" type="slidenum">
+              <a:rPr lang="en-US" smtClean="0"/>
+              <a:t>7</a:t>
+            </a:fld>
+            <a:endParaRPr lang="en-US"/>
+          </a:p>
+        </p:txBody>
+      </p:sp>
+    </p:spTree>
+    <p:extLst>
+      <p:ext uri="{BB962C8B-B14F-4D97-AF65-F5344CB8AC3E}">
+        <p14:creationId xmlns:p14="http://schemas.microsoft.com/office/powerpoint/2010/main" val="2188284980"/>
+      </p:ext>
+    </p:extLst>
+  </p:cSld>
+  <p:clrMapOvr>
+    <a:masterClrMapping/>
+  </p:clrMapOvr>
+</p:notes>
+</file>
+
+<file path=ppt/notesSlides/notesSlide7.xml><?xml version="1.0" encoding="utf-8"?>
+<p:notes xmlns:a="http://schemas.openxmlformats.org/drawingml/2006/main" xmlns:r="http://schemas.openxmlformats.org/officeDocument/2006/relationships" xmlns:p="http://schemas.openxmlformats.org/presentationml/2006/main">
+  <p:cSld>
+    <p:spTree>
+      <p:nvGrpSpPr>
+        <p:cNvPr id="1" name="">
+          <a:extLst>
+            <a:ext uri="{FF2B5EF4-FFF2-40B4-BE49-F238E27FC236}">
+              <a16:creationId xmlns:a16="http://schemas.microsoft.com/office/drawing/2014/main" id="{54F66BA1-76EF-F2D0-B0A3-2BECB91A517C}"/>
+            </a:ext>
+          </a:extLst>
+        </p:cNvPr>
+        <p:cNvGrpSpPr/>
+        <p:nvPr/>
+      </p:nvGrpSpPr>
+      <p:grpSpPr>
+        <a:xfrm>
+          <a:off x="0" y="0"/>
+          <a:ext cx="0" cy="0"/>
+          <a:chOff x="0" y="0"/>
+          <a:chExt cx="0" cy="0"/>
+        </a:xfrm>
+      </p:grpSpPr>
+      <p:sp>
+        <p:nvSpPr>
+          <p:cNvPr id="2" name="Slide Image Placeholder 1">
+            <a:extLst>
+              <a:ext uri="{FF2B5EF4-FFF2-40B4-BE49-F238E27FC236}">
+                <a16:creationId xmlns:a16="http://schemas.microsoft.com/office/drawing/2014/main" id="{ACD4C487-C49A-6203-2F7F-9A1AE8662828}"/>
+              </a:ext>
+            </a:extLst>
+          </p:cNvPr>
+          <p:cNvSpPr>
+            <a:spLocks noGrp="1" noRot="1" noChangeAspect="1"/>
+          </p:cNvSpPr>
+          <p:nvPr>
+            <p:ph type="sldImg"/>
+          </p:nvPr>
+        </p:nvSpPr>
+        <p:spPr/>
+      </p:sp>
+      <p:sp>
+        <p:nvSpPr>
+          <p:cNvPr id="3" name="Notes Placeholder 2">
+            <a:extLst>
+              <a:ext uri="{FF2B5EF4-FFF2-40B4-BE49-F238E27FC236}">
+                <a16:creationId xmlns:a16="http://schemas.microsoft.com/office/drawing/2014/main" id="{4301ACEC-48EB-2E2E-125B-8FFBCAA50ED4}"/>
+              </a:ext>
+            </a:extLst>
+          </p:cNvPr>
+          <p:cNvSpPr>
+            <a:spLocks noGrp="1"/>
+          </p:cNvSpPr>
+          <p:nvPr>
+            <p:ph type="body" idx="1"/>
+          </p:nvPr>
+        </p:nvSpPr>
+        <p:spPr/>
+        <p:txBody>
+          <a:bodyPr/>
+          <a:lstStyle/>
+          <a:p>
+            <a:r>
+              <a:rPr lang="en-US" dirty="0"/>
+              <a:t>Traces</a:t>
+            </a:r>
+          </a:p>
+          <a:p>
+            <a:r>
+              <a:rPr lang="en-US" dirty="0"/>
+              <a:t>Rep cell</a:t>
+            </a:r>
+          </a:p>
+          <a:p>
+            <a:r>
+              <a:rPr lang="en-US" dirty="0"/>
+              <a:t>PPR and CV</a:t>
+            </a:r>
+          </a:p>
+        </p:txBody>
+      </p:sp>
+      <p:sp>
+        <p:nvSpPr>
+          <p:cNvPr id="4" name="Slide Number Placeholder 3">
+            <a:extLst>
+              <a:ext uri="{FF2B5EF4-FFF2-40B4-BE49-F238E27FC236}">
+                <a16:creationId xmlns:a16="http://schemas.microsoft.com/office/drawing/2014/main" id="{055A50B9-5D5E-CFC0-57CD-255DBDB15704}"/>
+              </a:ext>
+            </a:extLst>
+          </p:cNvPr>
+          <p:cNvSpPr>
+            <a:spLocks noGrp="1"/>
+          </p:cNvSpPr>
+          <p:nvPr>
+            <p:ph type="sldNum" sz="quarter" idx="5"/>
+          </p:nvPr>
+        </p:nvSpPr>
+        <p:spPr/>
+        <p:txBody>
+          <a:bodyPr/>
+          <a:lstStyle/>
+          <a:p>
+            <a:fld id="{F708F06A-076A-AB49-9E02-15A3C27D2EF7}" type="slidenum">
+              <a:rPr lang="en-US" smtClean="0"/>
+              <a:t>8</a:t>
+            </a:fld>
+            <a:endParaRPr lang="en-US"/>
+          </a:p>
+        </p:txBody>
+      </p:sp>
+    </p:spTree>
+    <p:extLst>
+      <p:ext uri="{BB962C8B-B14F-4D97-AF65-F5344CB8AC3E}">
+        <p14:creationId xmlns:p14="http://schemas.microsoft.com/office/powerpoint/2010/main" val="727726667"/>
+      </p:ext>
+    </p:extLst>
+  </p:cSld>
+  <p:clrMapOvr>
+    <a:masterClrMapping/>
+  </p:clrMapOvr>
+</p:notes>
+</file>
+
+<file path=ppt/notesSlides/notesSlide8.xml><?xml version="1.0" encoding="utf-8"?>
+<p:notes xmlns:a="http://schemas.openxmlformats.org/drawingml/2006/main" xmlns:r="http://schemas.openxmlformats.org/officeDocument/2006/relationships" xmlns:p="http://schemas.openxmlformats.org/presentationml/2006/main">
+  <p:cSld>
+    <p:spTree>
+      <p:nvGrpSpPr>
+        <p:cNvPr id="1" name="">
+          <a:extLst>
+            <a:ext uri="{FF2B5EF4-FFF2-40B4-BE49-F238E27FC236}">
+              <a16:creationId xmlns:a16="http://schemas.microsoft.com/office/drawing/2014/main" id="{361C1861-6333-CF33-86DB-99096F16AC39}"/>
+            </a:ext>
+          </a:extLst>
+        </p:cNvPr>
+        <p:cNvGrpSpPr/>
+        <p:nvPr/>
+      </p:nvGrpSpPr>
+      <p:grpSpPr>
+        <a:xfrm>
+          <a:off x="0" y="0"/>
+          <a:ext cx="0" cy="0"/>
+          <a:chOff x="0" y="0"/>
+          <a:chExt cx="0" cy="0"/>
+        </a:xfrm>
+      </p:grpSpPr>
+      <p:sp>
+        <p:nvSpPr>
+          <p:cNvPr id="2" name="Slide Image Placeholder 1">
+            <a:extLst>
+              <a:ext uri="{FF2B5EF4-FFF2-40B4-BE49-F238E27FC236}">
+                <a16:creationId xmlns:a16="http://schemas.microsoft.com/office/drawing/2014/main" id="{B20E9660-0AE2-D107-C1E5-C05109A6F5A5}"/>
+              </a:ext>
+            </a:extLst>
+          </p:cNvPr>
+          <p:cNvSpPr>
+            <a:spLocks noGrp="1" noRot="1" noChangeAspect="1"/>
+          </p:cNvSpPr>
+          <p:nvPr>
+            <p:ph type="sldImg"/>
+          </p:nvPr>
+        </p:nvSpPr>
+        <p:spPr/>
+      </p:sp>
+      <p:sp>
+        <p:nvSpPr>
+          <p:cNvPr id="3" name="Notes Placeholder 2">
+            <a:extLst>
+              <a:ext uri="{FF2B5EF4-FFF2-40B4-BE49-F238E27FC236}">
+                <a16:creationId xmlns:a16="http://schemas.microsoft.com/office/drawing/2014/main" id="{07B7CAB0-B7C5-63E0-BF4D-C73A7996E4D6}"/>
+              </a:ext>
+            </a:extLst>
+          </p:cNvPr>
+          <p:cNvSpPr>
+            <a:spLocks noGrp="1"/>
+          </p:cNvSpPr>
+          <p:nvPr>
+            <p:ph type="body" idx="1"/>
+          </p:nvPr>
+        </p:nvSpPr>
+        <p:spPr/>
+        <p:txBody>
+          <a:bodyPr/>
+          <a:lstStyle/>
+          <a:p>
+            <a:r>
+              <a:rPr lang="en-US" dirty="0"/>
+              <a:t>Traces</a:t>
+            </a:r>
+          </a:p>
+          <a:p>
+            <a:r>
+              <a:rPr lang="en-US" dirty="0"/>
+              <a:t>Rep cell</a:t>
+            </a:r>
+          </a:p>
+          <a:p>
+            <a:r>
+              <a:rPr lang="en-US" dirty="0"/>
+              <a:t>PPR and CV</a:t>
+            </a:r>
+          </a:p>
+        </p:txBody>
+      </p:sp>
+      <p:sp>
+        <p:nvSpPr>
+          <p:cNvPr id="4" name="Slide Number Placeholder 3">
+            <a:extLst>
+              <a:ext uri="{FF2B5EF4-FFF2-40B4-BE49-F238E27FC236}">
+                <a16:creationId xmlns:a16="http://schemas.microsoft.com/office/drawing/2014/main" id="{66502CCE-1E7A-32BD-134A-334AA91EE634}"/>
+              </a:ext>
+            </a:extLst>
+          </p:cNvPr>
+          <p:cNvSpPr>
+            <a:spLocks noGrp="1"/>
+          </p:cNvSpPr>
+          <p:nvPr>
+            <p:ph type="sldNum" sz="quarter" idx="5"/>
+          </p:nvPr>
+        </p:nvSpPr>
+        <p:spPr/>
+        <p:txBody>
+          <a:bodyPr/>
+          <a:lstStyle/>
+          <a:p>
+            <a:fld id="{F708F06A-076A-AB49-9E02-15A3C27D2EF7}" type="slidenum">
+              <a:rPr lang="en-US" smtClean="0"/>
+              <a:t>9</a:t>
+            </a:fld>
+            <a:endParaRPr lang="en-US"/>
+          </a:p>
+        </p:txBody>
+      </p:sp>
+    </p:spTree>
+    <p:extLst>
+      <p:ext uri="{BB962C8B-B14F-4D97-AF65-F5344CB8AC3E}">
+        <p14:creationId xmlns:p14="http://schemas.microsoft.com/office/powerpoint/2010/main" val="1149316453"/>
+      </p:ext>
+    </p:extLst>
+  </p:cSld>
+  <p:clrMapOvr>
+    <a:masterClrMapping/>
+  </p:clrMapOvr>
+</p:notes>
+</file>
+
+<file path=ppt/notesSlides/notesSlide9.xml><?xml version="1.0" encoding="utf-8"?>
+<p:notes xmlns:a="http://schemas.openxmlformats.org/drawingml/2006/main" xmlns:r="http://schemas.openxmlformats.org/officeDocument/2006/relationships" xmlns:p="http://schemas.openxmlformats.org/presentationml/2006/main">
+  <p:cSld>
+    <p:spTree>
+      <p:nvGrpSpPr>
+        <p:cNvPr id="1" name="">
+          <a:extLst>
+            <a:ext uri="{FF2B5EF4-FFF2-40B4-BE49-F238E27FC236}">
+              <a16:creationId xmlns:a16="http://schemas.microsoft.com/office/drawing/2014/main" id="{23933D36-9617-4922-BBA0-DF9A6D4B4B55}"/>
+            </a:ext>
+          </a:extLst>
+        </p:cNvPr>
+        <p:cNvGrpSpPr/>
+        <p:nvPr/>
+      </p:nvGrpSpPr>
+      <p:grpSpPr>
+        <a:xfrm>
+          <a:off x="0" y="0"/>
+          <a:ext cx="0" cy="0"/>
+          <a:chOff x="0" y="0"/>
+          <a:chExt cx="0" cy="0"/>
+        </a:xfrm>
+      </p:grpSpPr>
+      <p:sp>
+        <p:nvSpPr>
+          <p:cNvPr id="2" name="Slide Image Placeholder 1">
+            <a:extLst>
+              <a:ext uri="{FF2B5EF4-FFF2-40B4-BE49-F238E27FC236}">
+                <a16:creationId xmlns:a16="http://schemas.microsoft.com/office/drawing/2014/main" id="{87F5D140-3394-2526-A45A-F326BF02D229}"/>
+              </a:ext>
+            </a:extLst>
+          </p:cNvPr>
+          <p:cNvSpPr>
+            <a:spLocks noGrp="1" noRot="1" noChangeAspect="1"/>
+          </p:cNvSpPr>
+          <p:nvPr>
+            <p:ph type="sldImg"/>
+          </p:nvPr>
+        </p:nvSpPr>
+        <p:spPr/>
+      </p:sp>
+      <p:sp>
+        <p:nvSpPr>
+          <p:cNvPr id="3" name="Notes Placeholder 2">
+            <a:extLst>
+              <a:ext uri="{FF2B5EF4-FFF2-40B4-BE49-F238E27FC236}">
+                <a16:creationId xmlns:a16="http://schemas.microsoft.com/office/drawing/2014/main" id="{0722751D-99FE-8DAC-8A2A-986CF6DD718F}"/>
+              </a:ext>
+            </a:extLst>
+          </p:cNvPr>
+          <p:cNvSpPr>
+            <a:spLocks noGrp="1"/>
+          </p:cNvSpPr>
+          <p:nvPr>
+            <p:ph type="body" idx="1"/>
+          </p:nvPr>
+        </p:nvSpPr>
+        <p:spPr/>
+        <p:txBody>
+          <a:bodyPr/>
+          <a:lstStyle/>
+          <a:p>
+            <a:r>
+              <a:rPr lang="en-US" dirty="0"/>
+              <a:t>Traces</a:t>
+            </a:r>
+          </a:p>
+          <a:p>
+            <a:r>
+              <a:rPr lang="en-US" dirty="0"/>
+              <a:t>Rep cell</a:t>
+            </a:r>
+          </a:p>
+          <a:p>
+            <a:r>
+              <a:rPr lang="en-US" dirty="0"/>
+              <a:t>PPR and CV</a:t>
+            </a:r>
+          </a:p>
+        </p:txBody>
+      </p:sp>
+      <p:sp>
+        <p:nvSpPr>
+          <p:cNvPr id="4" name="Slide Number Placeholder 3">
+            <a:extLst>
+              <a:ext uri="{FF2B5EF4-FFF2-40B4-BE49-F238E27FC236}">
+                <a16:creationId xmlns:a16="http://schemas.microsoft.com/office/drawing/2014/main" id="{5D563270-B8B0-2519-CA57-097FBE1BA4E1}"/>
+              </a:ext>
+            </a:extLst>
+          </p:cNvPr>
+          <p:cNvSpPr>
+            <a:spLocks noGrp="1"/>
+          </p:cNvSpPr>
+          <p:nvPr>
+            <p:ph type="sldNum" sz="quarter" idx="5"/>
+          </p:nvPr>
+        </p:nvSpPr>
+        <p:spPr/>
+        <p:txBody>
+          <a:bodyPr/>
+          <a:lstStyle/>
+          <a:p>
+            <a:fld id="{F708F06A-076A-AB49-9E02-15A3C27D2EF7}" type="slidenum">
+              <a:rPr lang="en-US" smtClean="0"/>
+              <a:t>10</a:t>
+            </a:fld>
+            <a:endParaRPr lang="en-US"/>
+          </a:p>
+        </p:txBody>
+      </p:sp>
+    </p:spTree>
+    <p:extLst>
+      <p:ext uri="{BB962C8B-B14F-4D97-AF65-F5344CB8AC3E}">
+        <p14:creationId xmlns:p14="http://schemas.microsoft.com/office/powerpoint/2010/main" val="1872765867"/>
+      </p:ext>
+    </p:extLst>
+  </p:cSld>
+  <p:clrMapOvr>
+    <a:masterClrMapping/>
+  </p:clrMapOvr>
+</p:notes>
+</file>
+
 <file path=ppt/slideLayouts/slideLayout1.xml><?xml version="1.0" encoding="utf-8"?>
 <p:sldLayout xmlns:a="http://schemas.openxmlformats.org/drawingml/2006/main" xmlns:r="http://schemas.openxmlformats.org/officeDocument/2006/relationships" xmlns:p="http://schemas.openxmlformats.org/presentationml/2006/main" type="title" preserve="1">
   <p:cSld name="Title Slide">
@@ -1446,7 +1918,7 @@
           <a:p>
             <a:fld id="{423AA46A-6E9F-7141-8668-6D3EB019C2A9}" type="datetimeFigureOut">
               <a:rPr lang="en-US" smtClean="0"/>
-              <a:t>3/3/26</a:t>
+              <a:t>4/5/26</a:t>
             </a:fld>
             <a:endParaRPr lang="en-US"/>
           </a:p>
@@ -1616,7 +2088,7 @@
           <a:p>
             <a:fld id="{423AA46A-6E9F-7141-8668-6D3EB019C2A9}" type="datetimeFigureOut">
               <a:rPr lang="en-US" smtClean="0"/>
-              <a:t>3/3/26</a:t>
+              <a:t>4/5/26</a:t>
             </a:fld>
             <a:endParaRPr lang="en-US"/>
           </a:p>
@@ -1796,7 +2268,7 @@
           <a:p>
             <a:fld id="{423AA46A-6E9F-7141-8668-6D3EB019C2A9}" type="datetimeFigureOut">
               <a:rPr lang="en-US" smtClean="0"/>
-              <a:t>3/3/26</a:t>
+              <a:t>4/5/26</a:t>
             </a:fld>
             <a:endParaRPr lang="en-US"/>
           </a:p>
@@ -1966,7 +2438,7 @@
           <a:p>
             <a:fld id="{423AA46A-6E9F-7141-8668-6D3EB019C2A9}" type="datetimeFigureOut">
               <a:rPr lang="en-US" smtClean="0"/>
-              <a:t>3/3/26</a:t>
+              <a:t>4/5/26</a:t>
             </a:fld>
             <a:endParaRPr lang="en-US"/>
           </a:p>
@@ -2212,7 +2684,7 @@
           <a:p>
             <a:fld id="{423AA46A-6E9F-7141-8668-6D3EB019C2A9}" type="datetimeFigureOut">
               <a:rPr lang="en-US" smtClean="0"/>
-              <a:t>3/3/26</a:t>
+              <a:t>4/5/26</a:t>
             </a:fld>
             <a:endParaRPr lang="en-US"/>
           </a:p>
@@ -2444,7 +2916,7 @@
           <a:p>
             <a:fld id="{423AA46A-6E9F-7141-8668-6D3EB019C2A9}" type="datetimeFigureOut">
               <a:rPr lang="en-US" smtClean="0"/>
-              <a:t>3/3/26</a:t>
+              <a:t>4/5/26</a:t>
             </a:fld>
             <a:endParaRPr lang="en-US"/>
           </a:p>
@@ -2811,7 +3283,7 @@
           <a:p>
             <a:fld id="{423AA46A-6E9F-7141-8668-6D3EB019C2A9}" type="datetimeFigureOut">
               <a:rPr lang="en-US" smtClean="0"/>
-              <a:t>3/3/26</a:t>
+              <a:t>4/5/26</a:t>
             </a:fld>
             <a:endParaRPr lang="en-US"/>
           </a:p>
@@ -2929,7 +3401,7 @@
           <a:p>
             <a:fld id="{423AA46A-6E9F-7141-8668-6D3EB019C2A9}" type="datetimeFigureOut">
               <a:rPr lang="en-US" smtClean="0"/>
-              <a:t>3/3/26</a:t>
+              <a:t>4/5/26</a:t>
             </a:fld>
             <a:endParaRPr lang="en-US"/>
           </a:p>
@@ -3024,7 +3496,7 @@
           <a:p>
             <a:fld id="{423AA46A-6E9F-7141-8668-6D3EB019C2A9}" type="datetimeFigureOut">
               <a:rPr lang="en-US" smtClean="0"/>
-              <a:t>3/3/26</a:t>
+              <a:t>4/5/26</a:t>
             </a:fld>
             <a:endParaRPr lang="en-US"/>
           </a:p>
@@ -3301,7 +3773,7 @@
           <a:p>
             <a:fld id="{423AA46A-6E9F-7141-8668-6D3EB019C2A9}" type="datetimeFigureOut">
               <a:rPr lang="en-US" smtClean="0"/>
-              <a:t>3/3/26</a:t>
+              <a:t>4/5/26</a:t>
             </a:fld>
             <a:endParaRPr lang="en-US"/>
           </a:p>
@@ -3558,7 +4030,7 @@
           <a:p>
             <a:fld id="{423AA46A-6E9F-7141-8668-6D3EB019C2A9}" type="datetimeFigureOut">
               <a:rPr lang="en-US" smtClean="0"/>
-              <a:t>3/3/26</a:t>
+              <a:t>4/5/26</a:t>
             </a:fld>
             <a:endParaRPr lang="en-US"/>
           </a:p>
@@ -3771,7 +4243,7 @@
           <a:p>
             <a:fld id="{423AA46A-6E9F-7141-8668-6D3EB019C2A9}" type="datetimeFigureOut">
               <a:rPr lang="en-US" smtClean="0"/>
-              <a:t>3/3/26</a:t>
+              <a:t>4/5/26</a:t>
             </a:fld>
             <a:endParaRPr lang="en-US"/>
           </a:p>
@@ -4593,6 +5065,329 @@
 </p:sld>
 </file>
 
+<file path=ppt/slides/slide10.xml><?xml version="1.0" encoding="utf-8"?>
+<p:sld xmlns:a="http://schemas.openxmlformats.org/drawingml/2006/main" xmlns:r="http://schemas.openxmlformats.org/officeDocument/2006/relationships" xmlns:p="http://schemas.openxmlformats.org/presentationml/2006/main">
+  <p:cSld>
+    <p:spTree>
+      <p:nvGrpSpPr>
+        <p:cNvPr id="1" name="">
+          <a:extLst>
+            <a:ext uri="{FF2B5EF4-FFF2-40B4-BE49-F238E27FC236}">
+              <a16:creationId xmlns:a16="http://schemas.microsoft.com/office/drawing/2014/main" id="{40C96E2F-B9A6-3702-240D-A7CEF015B4EC}"/>
+            </a:ext>
+          </a:extLst>
+        </p:cNvPr>
+        <p:cNvGrpSpPr/>
+        <p:nvPr/>
+      </p:nvGrpSpPr>
+      <p:grpSpPr>
+        <a:xfrm>
+          <a:off x="0" y="0"/>
+          <a:ext cx="0" cy="0"/>
+          <a:chOff x="0" y="0"/>
+          <a:chExt cx="0" cy="0"/>
+        </a:xfrm>
+      </p:grpSpPr>
+      <p:pic>
+        <p:nvPicPr>
+          <p:cNvPr id="4" name="Picture 3">
+            <a:extLst>
+              <a:ext uri="{FF2B5EF4-FFF2-40B4-BE49-F238E27FC236}">
+                <a16:creationId xmlns:a16="http://schemas.microsoft.com/office/drawing/2014/main" id="{041FE609-C7D0-B081-689E-638808D7145D}"/>
+              </a:ext>
+            </a:extLst>
+          </p:cNvPr>
+          <p:cNvPicPr>
+            <a:picLocks noChangeAspect="1"/>
+          </p:cNvPicPr>
+          <p:nvPr/>
+        </p:nvPicPr>
+        <p:blipFill>
+          <a:blip r:embed="rId3"/>
+          <a:srcRect/>
+          <a:stretch/>
+        </p:blipFill>
+        <p:spPr>
+          <a:xfrm>
+            <a:off x="4017659" y="6619159"/>
+            <a:ext cx="5123458" cy="1448298"/>
+          </a:xfrm>
+          <a:prstGeom prst="rect">
+            <a:avLst/>
+          </a:prstGeom>
+        </p:spPr>
+      </p:pic>
+      <p:pic>
+        <p:nvPicPr>
+          <p:cNvPr id="3" name="Picture 2">
+            <a:extLst>
+              <a:ext uri="{FF2B5EF4-FFF2-40B4-BE49-F238E27FC236}">
+                <a16:creationId xmlns:a16="http://schemas.microsoft.com/office/drawing/2014/main" id="{A7A2742D-B137-4497-87B4-B96BE1373A9F}"/>
+              </a:ext>
+            </a:extLst>
+          </p:cNvPr>
+          <p:cNvPicPr>
+            <a:picLocks noChangeAspect="1"/>
+          </p:cNvPicPr>
+          <p:nvPr/>
+        </p:nvPicPr>
+        <p:blipFill>
+          <a:blip r:embed="rId4"/>
+          <a:srcRect/>
+          <a:stretch/>
+        </p:blipFill>
+        <p:spPr>
+          <a:xfrm>
+            <a:off x="2753737" y="8161338"/>
+            <a:ext cx="6383067" cy="4571999"/>
+          </a:xfrm>
+          <a:prstGeom prst="rect">
+            <a:avLst/>
+          </a:prstGeom>
+        </p:spPr>
+      </p:pic>
+      <p:pic>
+        <p:nvPicPr>
+          <p:cNvPr id="7" name="Picture 6">
+            <a:extLst>
+              <a:ext uri="{FF2B5EF4-FFF2-40B4-BE49-F238E27FC236}">
+                <a16:creationId xmlns:a16="http://schemas.microsoft.com/office/drawing/2014/main" id="{4A1441D1-DB59-1D1E-CFF2-4C758561C743}"/>
+              </a:ext>
+            </a:extLst>
+          </p:cNvPr>
+          <p:cNvPicPr>
+            <a:picLocks noChangeAspect="1"/>
+          </p:cNvPicPr>
+          <p:nvPr/>
+        </p:nvPicPr>
+        <p:blipFill>
+          <a:blip r:embed="rId5"/>
+          <a:srcRect/>
+          <a:stretch/>
+        </p:blipFill>
+        <p:spPr>
+          <a:xfrm>
+            <a:off x="2766401" y="1794669"/>
+            <a:ext cx="6357739" cy="4571999"/>
+          </a:xfrm>
+          <a:prstGeom prst="rect">
+            <a:avLst/>
+          </a:prstGeom>
+        </p:spPr>
+      </p:pic>
+      <p:sp>
+        <p:nvSpPr>
+          <p:cNvPr id="8" name="TextBox 7">
+            <a:extLst>
+              <a:ext uri="{FF2B5EF4-FFF2-40B4-BE49-F238E27FC236}">
+                <a16:creationId xmlns:a16="http://schemas.microsoft.com/office/drawing/2014/main" id="{F83CF755-1063-4F86-C19D-A56C17756E51}"/>
+              </a:ext>
+            </a:extLst>
+          </p:cNvPr>
+          <p:cNvSpPr txBox="1"/>
+          <p:nvPr/>
+        </p:nvSpPr>
+        <p:spPr>
+          <a:xfrm>
+            <a:off x="2523718" y="1610163"/>
+            <a:ext cx="442301" cy="369012"/>
+          </a:xfrm>
+          <a:prstGeom prst="rect">
+            <a:avLst/>
+          </a:prstGeom>
+          <a:noFill/>
+        </p:spPr>
+        <p:txBody>
+          <a:bodyPr wrap="square" rtlCol="0">
+            <a:spAutoFit/>
+          </a:bodyPr>
+          <a:lstStyle/>
+          <a:p>
+            <a:r>
+              <a:rPr lang="en-US" sz="1798" b="1" dirty="0">
+                <a:latin typeface="Arial" panose="020B0604020202020204" pitchFamily="34" charset="0"/>
+                <a:cs typeface="Arial" panose="020B0604020202020204" pitchFamily="34" charset="0"/>
+              </a:rPr>
+              <a:t>A.</a:t>
+            </a:r>
+          </a:p>
+        </p:txBody>
+      </p:sp>
+      <p:sp>
+        <p:nvSpPr>
+          <p:cNvPr id="9" name="TextBox 8">
+            <a:extLst>
+              <a:ext uri="{FF2B5EF4-FFF2-40B4-BE49-F238E27FC236}">
+                <a16:creationId xmlns:a16="http://schemas.microsoft.com/office/drawing/2014/main" id="{03BFD00E-4D33-0433-5977-4844009545C4}"/>
+              </a:ext>
+            </a:extLst>
+          </p:cNvPr>
+          <p:cNvSpPr txBox="1"/>
+          <p:nvPr/>
+        </p:nvSpPr>
+        <p:spPr>
+          <a:xfrm>
+            <a:off x="2523718" y="5997657"/>
+            <a:ext cx="442301" cy="369012"/>
+          </a:xfrm>
+          <a:prstGeom prst="rect">
+            <a:avLst/>
+          </a:prstGeom>
+          <a:noFill/>
+        </p:spPr>
+        <p:txBody>
+          <a:bodyPr wrap="square" rtlCol="0">
+            <a:spAutoFit/>
+          </a:bodyPr>
+          <a:lstStyle/>
+          <a:p>
+            <a:r>
+              <a:rPr lang="en-US" sz="1798" b="1" dirty="0">
+                <a:latin typeface="Arial" panose="020B0604020202020204" pitchFamily="34" charset="0"/>
+                <a:cs typeface="Arial" panose="020B0604020202020204" pitchFamily="34" charset="0"/>
+              </a:rPr>
+              <a:t>B.</a:t>
+            </a:r>
+          </a:p>
+        </p:txBody>
+      </p:sp>
+      <p:sp>
+        <p:nvSpPr>
+          <p:cNvPr id="19" name="TextBox 18">
+            <a:extLst>
+              <a:ext uri="{FF2B5EF4-FFF2-40B4-BE49-F238E27FC236}">
+                <a16:creationId xmlns:a16="http://schemas.microsoft.com/office/drawing/2014/main" id="{AA491169-603F-0021-5738-B1FD86720F86}"/>
+              </a:ext>
+            </a:extLst>
+          </p:cNvPr>
+          <p:cNvSpPr txBox="1"/>
+          <p:nvPr/>
+        </p:nvSpPr>
+        <p:spPr>
+          <a:xfrm>
+            <a:off x="4218657" y="6448595"/>
+            <a:ext cx="951229" cy="338554"/>
+          </a:xfrm>
+          <a:prstGeom prst="rect">
+            <a:avLst/>
+          </a:prstGeom>
+          <a:noFill/>
+        </p:spPr>
+        <p:txBody>
+          <a:bodyPr wrap="square" rtlCol="0">
+            <a:spAutoFit/>
+          </a:bodyPr>
+          <a:lstStyle/>
+          <a:p>
+            <a:pPr algn="ctr"/>
+            <a:r>
+              <a:rPr lang="en-US" sz="1600" dirty="0">
+                <a:latin typeface="Segoe UI" panose="020B0502040204020203" pitchFamily="34" charset="0"/>
+                <a:cs typeface="Segoe UI" panose="020B0502040204020203" pitchFamily="34" charset="0"/>
+              </a:rPr>
+              <a:t>Baseline</a:t>
+            </a:r>
+            <a:endParaRPr lang="en-US" dirty="0">
+              <a:latin typeface="Segoe UI" panose="020B0502040204020203" pitchFamily="34" charset="0"/>
+              <a:cs typeface="Segoe UI" panose="020B0502040204020203" pitchFamily="34" charset="0"/>
+            </a:endParaRPr>
+          </a:p>
+        </p:txBody>
+      </p:sp>
+      <p:sp>
+        <p:nvSpPr>
+          <p:cNvPr id="20" name="TextBox 19">
+            <a:extLst>
+              <a:ext uri="{FF2B5EF4-FFF2-40B4-BE49-F238E27FC236}">
+                <a16:creationId xmlns:a16="http://schemas.microsoft.com/office/drawing/2014/main" id="{BDBB865D-889E-E10B-C428-333E270C1402}"/>
+              </a:ext>
+            </a:extLst>
+          </p:cNvPr>
+          <p:cNvSpPr txBox="1"/>
+          <p:nvPr/>
+        </p:nvSpPr>
+        <p:spPr>
+          <a:xfrm>
+            <a:off x="6184287" y="6448595"/>
+            <a:ext cx="1071546" cy="338554"/>
+          </a:xfrm>
+          <a:prstGeom prst="rect">
+            <a:avLst/>
+          </a:prstGeom>
+          <a:noFill/>
+        </p:spPr>
+        <p:txBody>
+          <a:bodyPr wrap="square" rtlCol="0">
+            <a:spAutoFit/>
+          </a:bodyPr>
+          <a:lstStyle/>
+          <a:p>
+            <a:pPr algn="ctr"/>
+            <a:r>
+              <a:rPr lang="en-US" sz="1600" dirty="0">
+                <a:latin typeface="Segoe UI" panose="020B0502040204020203" pitchFamily="34" charset="0"/>
+                <a:cs typeface="Segoe UI" panose="020B0502040204020203" pitchFamily="34" charset="0"/>
+              </a:rPr>
+              <a:t>Post-HFS</a:t>
+            </a:r>
+            <a:endParaRPr lang="en-US" dirty="0">
+              <a:latin typeface="Segoe UI" panose="020B0502040204020203" pitchFamily="34" charset="0"/>
+              <a:cs typeface="Segoe UI" panose="020B0502040204020203" pitchFamily="34" charset="0"/>
+            </a:endParaRPr>
+          </a:p>
+        </p:txBody>
+      </p:sp>
+      <p:sp>
+        <p:nvSpPr>
+          <p:cNvPr id="21" name="TextBox 20">
+            <a:extLst>
+              <a:ext uri="{FF2B5EF4-FFF2-40B4-BE49-F238E27FC236}">
+                <a16:creationId xmlns:a16="http://schemas.microsoft.com/office/drawing/2014/main" id="{3022C2CA-9CAF-1BBD-BB69-6C75E25366BE}"/>
+              </a:ext>
+            </a:extLst>
+          </p:cNvPr>
+          <p:cNvSpPr txBox="1"/>
+          <p:nvPr/>
+        </p:nvSpPr>
+        <p:spPr>
+          <a:xfrm>
+            <a:off x="2523718" y="7884238"/>
+            <a:ext cx="442301" cy="369012"/>
+          </a:xfrm>
+          <a:prstGeom prst="rect">
+            <a:avLst/>
+          </a:prstGeom>
+          <a:noFill/>
+        </p:spPr>
+        <p:txBody>
+          <a:bodyPr wrap="square" rtlCol="0">
+            <a:spAutoFit/>
+          </a:bodyPr>
+          <a:lstStyle/>
+          <a:p>
+            <a:r>
+              <a:rPr lang="en-US" sz="1798" b="1" dirty="0">
+                <a:latin typeface="Arial" panose="020B0604020202020204" pitchFamily="34" charset="0"/>
+                <a:cs typeface="Arial" panose="020B0604020202020204" pitchFamily="34" charset="0"/>
+              </a:rPr>
+              <a:t>C.</a:t>
+            </a:r>
+          </a:p>
+        </p:txBody>
+      </p:sp>
+    </p:spTree>
+    <p:extLst>
+      <p:ext uri="{BB962C8B-B14F-4D97-AF65-F5344CB8AC3E}">
+        <p14:creationId xmlns:p14="http://schemas.microsoft.com/office/powerpoint/2010/main" val="850732629"/>
+      </p:ext>
+    </p:extLst>
+  </p:cSld>
+  <p:clrMapOvr>
+    <a:masterClrMapping/>
+  </p:clrMapOvr>
+</p:sld>
+</file>
+
 <file path=ppt/slides/slide2.xml><?xml version="1.0" encoding="utf-8"?>
 <p:sld xmlns:a="http://schemas.openxmlformats.org/drawingml/2006/main" xmlns:r="http://schemas.openxmlformats.org/officeDocument/2006/relationships" xmlns:p="http://schemas.openxmlformats.org/presentationml/2006/main">
   <p:cSld>
@@ -5728,6 +6523,971 @@
     <p:extLst>
       <p:ext uri="{BB962C8B-B14F-4D97-AF65-F5344CB8AC3E}">
         <p14:creationId xmlns:p14="http://schemas.microsoft.com/office/powerpoint/2010/main" val="4168312661"/>
+      </p:ext>
+    </p:extLst>
+  </p:cSld>
+  <p:clrMapOvr>
+    <a:masterClrMapping/>
+  </p:clrMapOvr>
+</p:sld>
+</file>
+
+<file path=ppt/slides/slide7.xml><?xml version="1.0" encoding="utf-8"?>
+<p:sld xmlns:a="http://schemas.openxmlformats.org/drawingml/2006/main" xmlns:r="http://schemas.openxmlformats.org/officeDocument/2006/relationships" xmlns:p="http://schemas.openxmlformats.org/presentationml/2006/main">
+  <p:cSld>
+    <p:spTree>
+      <p:nvGrpSpPr>
+        <p:cNvPr id="1" name=""/>
+        <p:cNvGrpSpPr/>
+        <p:nvPr/>
+      </p:nvGrpSpPr>
+      <p:grpSpPr>
+        <a:xfrm>
+          <a:off x="0" y="0"/>
+          <a:ext cx="0" cy="0"/>
+          <a:chOff x="0" y="0"/>
+          <a:chExt cx="0" cy="0"/>
+        </a:xfrm>
+      </p:grpSpPr>
+      <p:pic>
+        <p:nvPicPr>
+          <p:cNvPr id="3" name="Picture 2">
+            <a:extLst>
+              <a:ext uri="{FF2B5EF4-FFF2-40B4-BE49-F238E27FC236}">
+                <a16:creationId xmlns:a16="http://schemas.microsoft.com/office/drawing/2014/main" id="{139E3991-F91C-0A33-8B5F-3BFF95493073}"/>
+              </a:ext>
+            </a:extLst>
+          </p:cNvPr>
+          <p:cNvPicPr>
+            <a:picLocks noChangeAspect="1"/>
+          </p:cNvPicPr>
+          <p:nvPr/>
+        </p:nvPicPr>
+        <p:blipFill>
+          <a:blip r:embed="rId3"/>
+          <a:stretch>
+            <a:fillRect/>
+          </a:stretch>
+        </p:blipFill>
+        <p:spPr>
+          <a:xfrm>
+            <a:off x="2744871" y="8161338"/>
+            <a:ext cx="6400800" cy="4572000"/>
+          </a:xfrm>
+          <a:prstGeom prst="rect">
+            <a:avLst/>
+          </a:prstGeom>
+        </p:spPr>
+      </p:pic>
+      <p:pic>
+        <p:nvPicPr>
+          <p:cNvPr id="7" name="Picture 6">
+            <a:extLst>
+              <a:ext uri="{FF2B5EF4-FFF2-40B4-BE49-F238E27FC236}">
+                <a16:creationId xmlns:a16="http://schemas.microsoft.com/office/drawing/2014/main" id="{83014362-6086-BB23-ABD3-D492511B7670}"/>
+              </a:ext>
+            </a:extLst>
+          </p:cNvPr>
+          <p:cNvPicPr>
+            <a:picLocks noChangeAspect="1"/>
+          </p:cNvPicPr>
+          <p:nvPr/>
+        </p:nvPicPr>
+        <p:blipFill>
+          <a:blip r:embed="rId4"/>
+          <a:stretch>
+            <a:fillRect/>
+          </a:stretch>
+        </p:blipFill>
+        <p:spPr>
+          <a:xfrm>
+            <a:off x="2744871" y="1794669"/>
+            <a:ext cx="6400800" cy="4572000"/>
+          </a:xfrm>
+          <a:prstGeom prst="rect">
+            <a:avLst/>
+          </a:prstGeom>
+        </p:spPr>
+      </p:pic>
+      <p:sp>
+        <p:nvSpPr>
+          <p:cNvPr id="8" name="TextBox 7">
+            <a:extLst>
+              <a:ext uri="{FF2B5EF4-FFF2-40B4-BE49-F238E27FC236}">
+                <a16:creationId xmlns:a16="http://schemas.microsoft.com/office/drawing/2014/main" id="{518656C9-7DDE-AA92-9A6F-B86984C97952}"/>
+              </a:ext>
+            </a:extLst>
+          </p:cNvPr>
+          <p:cNvSpPr txBox="1"/>
+          <p:nvPr/>
+        </p:nvSpPr>
+        <p:spPr>
+          <a:xfrm>
+            <a:off x="2523718" y="1610163"/>
+            <a:ext cx="442301" cy="369012"/>
+          </a:xfrm>
+          <a:prstGeom prst="rect">
+            <a:avLst/>
+          </a:prstGeom>
+          <a:noFill/>
+        </p:spPr>
+        <p:txBody>
+          <a:bodyPr wrap="square" rtlCol="0">
+            <a:spAutoFit/>
+          </a:bodyPr>
+          <a:lstStyle/>
+          <a:p>
+            <a:r>
+              <a:rPr lang="en-US" sz="1798" b="1" dirty="0">
+                <a:latin typeface="Arial" panose="020B0604020202020204" pitchFamily="34" charset="0"/>
+                <a:cs typeface="Arial" panose="020B0604020202020204" pitchFamily="34" charset="0"/>
+              </a:rPr>
+              <a:t>A.</a:t>
+            </a:r>
+          </a:p>
+        </p:txBody>
+      </p:sp>
+      <p:sp>
+        <p:nvSpPr>
+          <p:cNvPr id="9" name="TextBox 8">
+            <a:extLst>
+              <a:ext uri="{FF2B5EF4-FFF2-40B4-BE49-F238E27FC236}">
+                <a16:creationId xmlns:a16="http://schemas.microsoft.com/office/drawing/2014/main" id="{8F33D50D-3EDA-3259-F433-6359C59353A2}"/>
+              </a:ext>
+            </a:extLst>
+          </p:cNvPr>
+          <p:cNvSpPr txBox="1"/>
+          <p:nvPr/>
+        </p:nvSpPr>
+        <p:spPr>
+          <a:xfrm>
+            <a:off x="2523718" y="5997657"/>
+            <a:ext cx="442301" cy="369012"/>
+          </a:xfrm>
+          <a:prstGeom prst="rect">
+            <a:avLst/>
+          </a:prstGeom>
+          <a:noFill/>
+        </p:spPr>
+        <p:txBody>
+          <a:bodyPr wrap="square" rtlCol="0">
+            <a:spAutoFit/>
+          </a:bodyPr>
+          <a:lstStyle/>
+          <a:p>
+            <a:r>
+              <a:rPr lang="en-US" sz="1798" b="1" dirty="0">
+                <a:latin typeface="Arial" panose="020B0604020202020204" pitchFamily="34" charset="0"/>
+                <a:cs typeface="Arial" panose="020B0604020202020204" pitchFamily="34" charset="0"/>
+              </a:rPr>
+              <a:t>B.</a:t>
+            </a:r>
+          </a:p>
+        </p:txBody>
+      </p:sp>
+      <p:pic>
+        <p:nvPicPr>
+          <p:cNvPr id="18" name="Picture 17">
+            <a:extLst>
+              <a:ext uri="{FF2B5EF4-FFF2-40B4-BE49-F238E27FC236}">
+                <a16:creationId xmlns:a16="http://schemas.microsoft.com/office/drawing/2014/main" id="{EC68AC3F-A8D5-5784-E4E3-2E49AB381641}"/>
+              </a:ext>
+            </a:extLst>
+          </p:cNvPr>
+          <p:cNvPicPr>
+            <a:picLocks noChangeAspect="1"/>
+          </p:cNvPicPr>
+          <p:nvPr/>
+        </p:nvPicPr>
+        <p:blipFill>
+          <a:blip r:embed="rId5"/>
+          <a:srcRect/>
+          <a:stretch/>
+        </p:blipFill>
+        <p:spPr>
+          <a:xfrm>
+            <a:off x="4013105" y="6617872"/>
+            <a:ext cx="5132566" cy="1450872"/>
+          </a:xfrm>
+          <a:prstGeom prst="rect">
+            <a:avLst/>
+          </a:prstGeom>
+        </p:spPr>
+      </p:pic>
+      <p:sp>
+        <p:nvSpPr>
+          <p:cNvPr id="19" name="TextBox 18">
+            <a:extLst>
+              <a:ext uri="{FF2B5EF4-FFF2-40B4-BE49-F238E27FC236}">
+                <a16:creationId xmlns:a16="http://schemas.microsoft.com/office/drawing/2014/main" id="{315674EE-39E8-5A0E-4840-41FF5FCBE0D3}"/>
+              </a:ext>
+            </a:extLst>
+          </p:cNvPr>
+          <p:cNvSpPr txBox="1"/>
+          <p:nvPr/>
+        </p:nvSpPr>
+        <p:spPr>
+          <a:xfrm>
+            <a:off x="4218657" y="6448595"/>
+            <a:ext cx="951229" cy="338554"/>
+          </a:xfrm>
+          <a:prstGeom prst="rect">
+            <a:avLst/>
+          </a:prstGeom>
+          <a:noFill/>
+        </p:spPr>
+        <p:txBody>
+          <a:bodyPr wrap="square" rtlCol="0">
+            <a:spAutoFit/>
+          </a:bodyPr>
+          <a:lstStyle/>
+          <a:p>
+            <a:pPr algn="ctr"/>
+            <a:r>
+              <a:rPr lang="en-US" sz="1600" dirty="0">
+                <a:latin typeface="Segoe UI" panose="020B0502040204020203" pitchFamily="34" charset="0"/>
+                <a:cs typeface="Segoe UI" panose="020B0502040204020203" pitchFamily="34" charset="0"/>
+              </a:rPr>
+              <a:t>Baseline</a:t>
+            </a:r>
+            <a:endParaRPr lang="en-US" dirty="0">
+              <a:latin typeface="Segoe UI" panose="020B0502040204020203" pitchFamily="34" charset="0"/>
+              <a:cs typeface="Segoe UI" panose="020B0502040204020203" pitchFamily="34" charset="0"/>
+            </a:endParaRPr>
+          </a:p>
+        </p:txBody>
+      </p:sp>
+      <p:sp>
+        <p:nvSpPr>
+          <p:cNvPr id="20" name="TextBox 19">
+            <a:extLst>
+              <a:ext uri="{FF2B5EF4-FFF2-40B4-BE49-F238E27FC236}">
+                <a16:creationId xmlns:a16="http://schemas.microsoft.com/office/drawing/2014/main" id="{98FB0E35-D2B3-A754-A053-6C9AE9B2B42C}"/>
+              </a:ext>
+            </a:extLst>
+          </p:cNvPr>
+          <p:cNvSpPr txBox="1"/>
+          <p:nvPr/>
+        </p:nvSpPr>
+        <p:spPr>
+          <a:xfrm>
+            <a:off x="6184287" y="6448595"/>
+            <a:ext cx="1071546" cy="338554"/>
+          </a:xfrm>
+          <a:prstGeom prst="rect">
+            <a:avLst/>
+          </a:prstGeom>
+          <a:noFill/>
+        </p:spPr>
+        <p:txBody>
+          <a:bodyPr wrap="square" rtlCol="0">
+            <a:spAutoFit/>
+          </a:bodyPr>
+          <a:lstStyle/>
+          <a:p>
+            <a:pPr algn="ctr"/>
+            <a:r>
+              <a:rPr lang="en-US" sz="1600" dirty="0">
+                <a:latin typeface="Segoe UI" panose="020B0502040204020203" pitchFamily="34" charset="0"/>
+                <a:cs typeface="Segoe UI" panose="020B0502040204020203" pitchFamily="34" charset="0"/>
+              </a:rPr>
+              <a:t>Post-HFS</a:t>
+            </a:r>
+            <a:endParaRPr lang="en-US" dirty="0">
+              <a:latin typeface="Segoe UI" panose="020B0502040204020203" pitchFamily="34" charset="0"/>
+              <a:cs typeface="Segoe UI" panose="020B0502040204020203" pitchFamily="34" charset="0"/>
+            </a:endParaRPr>
+          </a:p>
+        </p:txBody>
+      </p:sp>
+      <p:sp>
+        <p:nvSpPr>
+          <p:cNvPr id="21" name="TextBox 20">
+            <a:extLst>
+              <a:ext uri="{FF2B5EF4-FFF2-40B4-BE49-F238E27FC236}">
+                <a16:creationId xmlns:a16="http://schemas.microsoft.com/office/drawing/2014/main" id="{AE3CC6D3-AB43-1E7F-F8F4-EB407E5FEAD4}"/>
+              </a:ext>
+            </a:extLst>
+          </p:cNvPr>
+          <p:cNvSpPr txBox="1"/>
+          <p:nvPr/>
+        </p:nvSpPr>
+        <p:spPr>
+          <a:xfrm>
+            <a:off x="2523718" y="7884238"/>
+            <a:ext cx="442301" cy="369012"/>
+          </a:xfrm>
+          <a:prstGeom prst="rect">
+            <a:avLst/>
+          </a:prstGeom>
+          <a:noFill/>
+        </p:spPr>
+        <p:txBody>
+          <a:bodyPr wrap="square" rtlCol="0">
+            <a:spAutoFit/>
+          </a:bodyPr>
+          <a:lstStyle/>
+          <a:p>
+            <a:r>
+              <a:rPr lang="en-US" sz="1798" b="1" dirty="0">
+                <a:latin typeface="Arial" panose="020B0604020202020204" pitchFamily="34" charset="0"/>
+                <a:cs typeface="Arial" panose="020B0604020202020204" pitchFamily="34" charset="0"/>
+              </a:rPr>
+              <a:t>C.</a:t>
+            </a:r>
+          </a:p>
+        </p:txBody>
+      </p:sp>
+    </p:spTree>
+    <p:extLst>
+      <p:ext uri="{BB962C8B-B14F-4D97-AF65-F5344CB8AC3E}">
+        <p14:creationId xmlns:p14="http://schemas.microsoft.com/office/powerpoint/2010/main" val="1340584193"/>
+      </p:ext>
+    </p:extLst>
+  </p:cSld>
+  <p:clrMapOvr>
+    <a:masterClrMapping/>
+  </p:clrMapOvr>
+</p:sld>
+</file>
+
+<file path=ppt/slides/slide8.xml><?xml version="1.0" encoding="utf-8"?>
+<p:sld xmlns:a="http://schemas.openxmlformats.org/drawingml/2006/main" xmlns:r="http://schemas.openxmlformats.org/officeDocument/2006/relationships" xmlns:p="http://schemas.openxmlformats.org/presentationml/2006/main">
+  <p:cSld>
+    <p:spTree>
+      <p:nvGrpSpPr>
+        <p:cNvPr id="1" name="">
+          <a:extLst>
+            <a:ext uri="{FF2B5EF4-FFF2-40B4-BE49-F238E27FC236}">
+              <a16:creationId xmlns:a16="http://schemas.microsoft.com/office/drawing/2014/main" id="{AE009488-6750-E636-3C4C-84FDBBF1783E}"/>
+            </a:ext>
+          </a:extLst>
+        </p:cNvPr>
+        <p:cNvGrpSpPr/>
+        <p:nvPr/>
+      </p:nvGrpSpPr>
+      <p:grpSpPr>
+        <a:xfrm>
+          <a:off x="0" y="0"/>
+          <a:ext cx="0" cy="0"/>
+          <a:chOff x="0" y="0"/>
+          <a:chExt cx="0" cy="0"/>
+        </a:xfrm>
+      </p:grpSpPr>
+      <p:pic>
+        <p:nvPicPr>
+          <p:cNvPr id="3" name="Picture 2">
+            <a:extLst>
+              <a:ext uri="{FF2B5EF4-FFF2-40B4-BE49-F238E27FC236}">
+                <a16:creationId xmlns:a16="http://schemas.microsoft.com/office/drawing/2014/main" id="{9B69B228-8A4E-137F-FD80-E00059299F6E}"/>
+              </a:ext>
+            </a:extLst>
+          </p:cNvPr>
+          <p:cNvPicPr>
+            <a:picLocks noChangeAspect="1"/>
+          </p:cNvPicPr>
+          <p:nvPr/>
+        </p:nvPicPr>
+        <p:blipFill>
+          <a:blip r:embed="rId3"/>
+          <a:srcRect/>
+          <a:stretch/>
+        </p:blipFill>
+        <p:spPr>
+          <a:xfrm>
+            <a:off x="2753736" y="8161338"/>
+            <a:ext cx="6383069" cy="4572000"/>
+          </a:xfrm>
+          <a:prstGeom prst="rect">
+            <a:avLst/>
+          </a:prstGeom>
+        </p:spPr>
+      </p:pic>
+      <p:pic>
+        <p:nvPicPr>
+          <p:cNvPr id="7" name="Picture 6">
+            <a:extLst>
+              <a:ext uri="{FF2B5EF4-FFF2-40B4-BE49-F238E27FC236}">
+                <a16:creationId xmlns:a16="http://schemas.microsoft.com/office/drawing/2014/main" id="{CC6EADE1-4E2A-F6B0-4F2B-184978D6A847}"/>
+              </a:ext>
+            </a:extLst>
+          </p:cNvPr>
+          <p:cNvPicPr>
+            <a:picLocks noChangeAspect="1"/>
+          </p:cNvPicPr>
+          <p:nvPr/>
+        </p:nvPicPr>
+        <p:blipFill>
+          <a:blip r:embed="rId4"/>
+          <a:srcRect/>
+          <a:stretch/>
+        </p:blipFill>
+        <p:spPr>
+          <a:xfrm>
+            <a:off x="2760069" y="1794669"/>
+            <a:ext cx="6370404" cy="4572000"/>
+          </a:xfrm>
+          <a:prstGeom prst="rect">
+            <a:avLst/>
+          </a:prstGeom>
+        </p:spPr>
+      </p:pic>
+      <p:sp>
+        <p:nvSpPr>
+          <p:cNvPr id="8" name="TextBox 7">
+            <a:extLst>
+              <a:ext uri="{FF2B5EF4-FFF2-40B4-BE49-F238E27FC236}">
+                <a16:creationId xmlns:a16="http://schemas.microsoft.com/office/drawing/2014/main" id="{526FF42C-EE63-A09B-8579-3C3FC82A4FC4}"/>
+              </a:ext>
+            </a:extLst>
+          </p:cNvPr>
+          <p:cNvSpPr txBox="1"/>
+          <p:nvPr/>
+        </p:nvSpPr>
+        <p:spPr>
+          <a:xfrm>
+            <a:off x="2523718" y="1610163"/>
+            <a:ext cx="442301" cy="369012"/>
+          </a:xfrm>
+          <a:prstGeom prst="rect">
+            <a:avLst/>
+          </a:prstGeom>
+          <a:noFill/>
+        </p:spPr>
+        <p:txBody>
+          <a:bodyPr wrap="square" rtlCol="0">
+            <a:spAutoFit/>
+          </a:bodyPr>
+          <a:lstStyle/>
+          <a:p>
+            <a:r>
+              <a:rPr lang="en-US" sz="1798" b="1" dirty="0">
+                <a:latin typeface="Arial" panose="020B0604020202020204" pitchFamily="34" charset="0"/>
+                <a:cs typeface="Arial" panose="020B0604020202020204" pitchFamily="34" charset="0"/>
+              </a:rPr>
+              <a:t>A.</a:t>
+            </a:r>
+          </a:p>
+        </p:txBody>
+      </p:sp>
+      <p:sp>
+        <p:nvSpPr>
+          <p:cNvPr id="9" name="TextBox 8">
+            <a:extLst>
+              <a:ext uri="{FF2B5EF4-FFF2-40B4-BE49-F238E27FC236}">
+                <a16:creationId xmlns:a16="http://schemas.microsoft.com/office/drawing/2014/main" id="{9F228C08-5C6D-C0AB-EB74-B5B4098C7CF0}"/>
+              </a:ext>
+            </a:extLst>
+          </p:cNvPr>
+          <p:cNvSpPr txBox="1"/>
+          <p:nvPr/>
+        </p:nvSpPr>
+        <p:spPr>
+          <a:xfrm>
+            <a:off x="2523718" y="5997657"/>
+            <a:ext cx="442301" cy="369012"/>
+          </a:xfrm>
+          <a:prstGeom prst="rect">
+            <a:avLst/>
+          </a:prstGeom>
+          <a:noFill/>
+        </p:spPr>
+        <p:txBody>
+          <a:bodyPr wrap="square" rtlCol="0">
+            <a:spAutoFit/>
+          </a:bodyPr>
+          <a:lstStyle/>
+          <a:p>
+            <a:r>
+              <a:rPr lang="en-US" sz="1798" b="1" dirty="0">
+                <a:latin typeface="Arial" panose="020B0604020202020204" pitchFamily="34" charset="0"/>
+                <a:cs typeface="Arial" panose="020B0604020202020204" pitchFamily="34" charset="0"/>
+              </a:rPr>
+              <a:t>B.</a:t>
+            </a:r>
+          </a:p>
+        </p:txBody>
+      </p:sp>
+      <p:pic>
+        <p:nvPicPr>
+          <p:cNvPr id="18" name="Picture 17">
+            <a:extLst>
+              <a:ext uri="{FF2B5EF4-FFF2-40B4-BE49-F238E27FC236}">
+                <a16:creationId xmlns:a16="http://schemas.microsoft.com/office/drawing/2014/main" id="{6C336446-D2F9-1E17-EA9E-59D98FEBE412}"/>
+              </a:ext>
+            </a:extLst>
+          </p:cNvPr>
+          <p:cNvPicPr>
+            <a:picLocks noChangeAspect="1"/>
+          </p:cNvPicPr>
+          <p:nvPr/>
+        </p:nvPicPr>
+        <p:blipFill>
+          <a:blip r:embed="rId5"/>
+          <a:srcRect/>
+          <a:stretch/>
+        </p:blipFill>
+        <p:spPr>
+          <a:xfrm>
+            <a:off x="4013105" y="6619159"/>
+            <a:ext cx="5132566" cy="1448298"/>
+          </a:xfrm>
+          <a:prstGeom prst="rect">
+            <a:avLst/>
+          </a:prstGeom>
+        </p:spPr>
+      </p:pic>
+      <p:sp>
+        <p:nvSpPr>
+          <p:cNvPr id="19" name="TextBox 18">
+            <a:extLst>
+              <a:ext uri="{FF2B5EF4-FFF2-40B4-BE49-F238E27FC236}">
+                <a16:creationId xmlns:a16="http://schemas.microsoft.com/office/drawing/2014/main" id="{F464DBB6-D776-53EC-FB5D-31636CA75ED9}"/>
+              </a:ext>
+            </a:extLst>
+          </p:cNvPr>
+          <p:cNvSpPr txBox="1"/>
+          <p:nvPr/>
+        </p:nvSpPr>
+        <p:spPr>
+          <a:xfrm>
+            <a:off x="4218657" y="6448595"/>
+            <a:ext cx="951229" cy="338554"/>
+          </a:xfrm>
+          <a:prstGeom prst="rect">
+            <a:avLst/>
+          </a:prstGeom>
+          <a:noFill/>
+        </p:spPr>
+        <p:txBody>
+          <a:bodyPr wrap="square" rtlCol="0">
+            <a:spAutoFit/>
+          </a:bodyPr>
+          <a:lstStyle/>
+          <a:p>
+            <a:pPr algn="ctr"/>
+            <a:r>
+              <a:rPr lang="en-US" sz="1600" dirty="0">
+                <a:latin typeface="Segoe UI" panose="020B0502040204020203" pitchFamily="34" charset="0"/>
+                <a:cs typeface="Segoe UI" panose="020B0502040204020203" pitchFamily="34" charset="0"/>
+              </a:rPr>
+              <a:t>Baseline</a:t>
+            </a:r>
+            <a:endParaRPr lang="en-US" dirty="0">
+              <a:latin typeface="Segoe UI" panose="020B0502040204020203" pitchFamily="34" charset="0"/>
+              <a:cs typeface="Segoe UI" panose="020B0502040204020203" pitchFamily="34" charset="0"/>
+            </a:endParaRPr>
+          </a:p>
+        </p:txBody>
+      </p:sp>
+      <p:sp>
+        <p:nvSpPr>
+          <p:cNvPr id="20" name="TextBox 19">
+            <a:extLst>
+              <a:ext uri="{FF2B5EF4-FFF2-40B4-BE49-F238E27FC236}">
+                <a16:creationId xmlns:a16="http://schemas.microsoft.com/office/drawing/2014/main" id="{43510C4B-0301-8885-455B-D20AAD1D85B6}"/>
+              </a:ext>
+            </a:extLst>
+          </p:cNvPr>
+          <p:cNvSpPr txBox="1"/>
+          <p:nvPr/>
+        </p:nvSpPr>
+        <p:spPr>
+          <a:xfrm>
+            <a:off x="6184287" y="6448595"/>
+            <a:ext cx="1071546" cy="338554"/>
+          </a:xfrm>
+          <a:prstGeom prst="rect">
+            <a:avLst/>
+          </a:prstGeom>
+          <a:noFill/>
+        </p:spPr>
+        <p:txBody>
+          <a:bodyPr wrap="square" rtlCol="0">
+            <a:spAutoFit/>
+          </a:bodyPr>
+          <a:lstStyle/>
+          <a:p>
+            <a:pPr algn="ctr"/>
+            <a:r>
+              <a:rPr lang="en-US" sz="1600" dirty="0">
+                <a:latin typeface="Segoe UI" panose="020B0502040204020203" pitchFamily="34" charset="0"/>
+                <a:cs typeface="Segoe UI" panose="020B0502040204020203" pitchFamily="34" charset="0"/>
+              </a:rPr>
+              <a:t>Post-HFS</a:t>
+            </a:r>
+            <a:endParaRPr lang="en-US" dirty="0">
+              <a:latin typeface="Segoe UI" panose="020B0502040204020203" pitchFamily="34" charset="0"/>
+              <a:cs typeface="Segoe UI" panose="020B0502040204020203" pitchFamily="34" charset="0"/>
+            </a:endParaRPr>
+          </a:p>
+        </p:txBody>
+      </p:sp>
+      <p:sp>
+        <p:nvSpPr>
+          <p:cNvPr id="21" name="TextBox 20">
+            <a:extLst>
+              <a:ext uri="{FF2B5EF4-FFF2-40B4-BE49-F238E27FC236}">
+                <a16:creationId xmlns:a16="http://schemas.microsoft.com/office/drawing/2014/main" id="{7BFE4CEA-0832-699F-3D66-4159DC369D7F}"/>
+              </a:ext>
+            </a:extLst>
+          </p:cNvPr>
+          <p:cNvSpPr txBox="1"/>
+          <p:nvPr/>
+        </p:nvSpPr>
+        <p:spPr>
+          <a:xfrm>
+            <a:off x="2523718" y="7884238"/>
+            <a:ext cx="442301" cy="369012"/>
+          </a:xfrm>
+          <a:prstGeom prst="rect">
+            <a:avLst/>
+          </a:prstGeom>
+          <a:noFill/>
+        </p:spPr>
+        <p:txBody>
+          <a:bodyPr wrap="square" rtlCol="0">
+            <a:spAutoFit/>
+          </a:bodyPr>
+          <a:lstStyle/>
+          <a:p>
+            <a:r>
+              <a:rPr lang="en-US" sz="1798" b="1" dirty="0">
+                <a:latin typeface="Arial" panose="020B0604020202020204" pitchFamily="34" charset="0"/>
+                <a:cs typeface="Arial" panose="020B0604020202020204" pitchFamily="34" charset="0"/>
+              </a:rPr>
+              <a:t>C.</a:t>
+            </a:r>
+          </a:p>
+        </p:txBody>
+      </p:sp>
+    </p:spTree>
+    <p:extLst>
+      <p:ext uri="{BB962C8B-B14F-4D97-AF65-F5344CB8AC3E}">
+        <p14:creationId xmlns:p14="http://schemas.microsoft.com/office/powerpoint/2010/main" val="2689135982"/>
+      </p:ext>
+    </p:extLst>
+  </p:cSld>
+  <p:clrMapOvr>
+    <a:masterClrMapping/>
+  </p:clrMapOvr>
+</p:sld>
+</file>
+
+<file path=ppt/slides/slide9.xml><?xml version="1.0" encoding="utf-8"?>
+<p:sld xmlns:a="http://schemas.openxmlformats.org/drawingml/2006/main" xmlns:r="http://schemas.openxmlformats.org/officeDocument/2006/relationships" xmlns:p="http://schemas.openxmlformats.org/presentationml/2006/main">
+  <p:cSld>
+    <p:spTree>
+      <p:nvGrpSpPr>
+        <p:cNvPr id="1" name="">
+          <a:extLst>
+            <a:ext uri="{FF2B5EF4-FFF2-40B4-BE49-F238E27FC236}">
+              <a16:creationId xmlns:a16="http://schemas.microsoft.com/office/drawing/2014/main" id="{A062D1D4-6826-F620-B10A-784FC5BF51AC}"/>
+            </a:ext>
+          </a:extLst>
+        </p:cNvPr>
+        <p:cNvGrpSpPr/>
+        <p:nvPr/>
+      </p:nvGrpSpPr>
+      <p:grpSpPr>
+        <a:xfrm>
+          <a:off x="0" y="0"/>
+          <a:ext cx="0" cy="0"/>
+          <a:chOff x="0" y="0"/>
+          <a:chExt cx="0" cy="0"/>
+        </a:xfrm>
+      </p:grpSpPr>
+      <p:pic>
+        <p:nvPicPr>
+          <p:cNvPr id="3" name="Picture 2">
+            <a:extLst>
+              <a:ext uri="{FF2B5EF4-FFF2-40B4-BE49-F238E27FC236}">
+                <a16:creationId xmlns:a16="http://schemas.microsoft.com/office/drawing/2014/main" id="{DCA7BD25-3893-16E8-50D3-96F5DC450AB5}"/>
+              </a:ext>
+            </a:extLst>
+          </p:cNvPr>
+          <p:cNvPicPr>
+            <a:picLocks noChangeAspect="1"/>
+          </p:cNvPicPr>
+          <p:nvPr/>
+        </p:nvPicPr>
+        <p:blipFill>
+          <a:blip r:embed="rId3"/>
+          <a:srcRect/>
+          <a:stretch/>
+        </p:blipFill>
+        <p:spPr>
+          <a:xfrm>
+            <a:off x="2753736" y="8161338"/>
+            <a:ext cx="6383069" cy="4571999"/>
+          </a:xfrm>
+          <a:prstGeom prst="rect">
+            <a:avLst/>
+          </a:prstGeom>
+        </p:spPr>
+      </p:pic>
+      <p:pic>
+        <p:nvPicPr>
+          <p:cNvPr id="7" name="Picture 6">
+            <a:extLst>
+              <a:ext uri="{FF2B5EF4-FFF2-40B4-BE49-F238E27FC236}">
+                <a16:creationId xmlns:a16="http://schemas.microsoft.com/office/drawing/2014/main" id="{26442BF3-2E38-C0D4-F101-98AC5033DE28}"/>
+              </a:ext>
+            </a:extLst>
+          </p:cNvPr>
+          <p:cNvPicPr>
+            <a:picLocks noChangeAspect="1"/>
+          </p:cNvPicPr>
+          <p:nvPr/>
+        </p:nvPicPr>
+        <p:blipFill>
+          <a:blip r:embed="rId4"/>
+          <a:srcRect/>
+          <a:stretch/>
+        </p:blipFill>
+        <p:spPr>
+          <a:xfrm>
+            <a:off x="2766401" y="1794669"/>
+            <a:ext cx="6357739" cy="4572000"/>
+          </a:xfrm>
+          <a:prstGeom prst="rect">
+            <a:avLst/>
+          </a:prstGeom>
+        </p:spPr>
+      </p:pic>
+      <p:sp>
+        <p:nvSpPr>
+          <p:cNvPr id="8" name="TextBox 7">
+            <a:extLst>
+              <a:ext uri="{FF2B5EF4-FFF2-40B4-BE49-F238E27FC236}">
+                <a16:creationId xmlns:a16="http://schemas.microsoft.com/office/drawing/2014/main" id="{A56BEC6A-47CB-F436-4913-67FCED4CB003}"/>
+              </a:ext>
+            </a:extLst>
+          </p:cNvPr>
+          <p:cNvSpPr txBox="1"/>
+          <p:nvPr/>
+        </p:nvSpPr>
+        <p:spPr>
+          <a:xfrm>
+            <a:off x="2523718" y="1610163"/>
+            <a:ext cx="442301" cy="369012"/>
+          </a:xfrm>
+          <a:prstGeom prst="rect">
+            <a:avLst/>
+          </a:prstGeom>
+          <a:noFill/>
+        </p:spPr>
+        <p:txBody>
+          <a:bodyPr wrap="square" rtlCol="0">
+            <a:spAutoFit/>
+          </a:bodyPr>
+          <a:lstStyle/>
+          <a:p>
+            <a:r>
+              <a:rPr lang="en-US" sz="1798" b="1" dirty="0">
+                <a:latin typeface="Arial" panose="020B0604020202020204" pitchFamily="34" charset="0"/>
+                <a:cs typeface="Arial" panose="020B0604020202020204" pitchFamily="34" charset="0"/>
+              </a:rPr>
+              <a:t>A.</a:t>
+            </a:r>
+          </a:p>
+        </p:txBody>
+      </p:sp>
+      <p:sp>
+        <p:nvSpPr>
+          <p:cNvPr id="9" name="TextBox 8">
+            <a:extLst>
+              <a:ext uri="{FF2B5EF4-FFF2-40B4-BE49-F238E27FC236}">
+                <a16:creationId xmlns:a16="http://schemas.microsoft.com/office/drawing/2014/main" id="{49E28428-4C66-9E54-C23C-52FF8C2B8609}"/>
+              </a:ext>
+            </a:extLst>
+          </p:cNvPr>
+          <p:cNvSpPr txBox="1"/>
+          <p:nvPr/>
+        </p:nvSpPr>
+        <p:spPr>
+          <a:xfrm>
+            <a:off x="2523718" y="5997657"/>
+            <a:ext cx="442301" cy="369012"/>
+          </a:xfrm>
+          <a:prstGeom prst="rect">
+            <a:avLst/>
+          </a:prstGeom>
+          <a:noFill/>
+        </p:spPr>
+        <p:txBody>
+          <a:bodyPr wrap="square" rtlCol="0">
+            <a:spAutoFit/>
+          </a:bodyPr>
+          <a:lstStyle/>
+          <a:p>
+            <a:r>
+              <a:rPr lang="en-US" sz="1798" b="1" dirty="0">
+                <a:latin typeface="Arial" panose="020B0604020202020204" pitchFamily="34" charset="0"/>
+                <a:cs typeface="Arial" panose="020B0604020202020204" pitchFamily="34" charset="0"/>
+              </a:rPr>
+              <a:t>B.</a:t>
+            </a:r>
+          </a:p>
+        </p:txBody>
+      </p:sp>
+      <p:pic>
+        <p:nvPicPr>
+          <p:cNvPr id="18" name="Picture 17">
+            <a:extLst>
+              <a:ext uri="{FF2B5EF4-FFF2-40B4-BE49-F238E27FC236}">
+                <a16:creationId xmlns:a16="http://schemas.microsoft.com/office/drawing/2014/main" id="{9FFCC96E-5C71-5BD9-2B52-2755E50BAF35}"/>
+              </a:ext>
+            </a:extLst>
+          </p:cNvPr>
+          <p:cNvPicPr>
+            <a:picLocks noChangeAspect="1"/>
+          </p:cNvPicPr>
+          <p:nvPr/>
+        </p:nvPicPr>
+        <p:blipFill>
+          <a:blip r:embed="rId5"/>
+          <a:srcRect/>
+          <a:stretch/>
+        </p:blipFill>
+        <p:spPr>
+          <a:xfrm>
+            <a:off x="4013106" y="6619159"/>
+            <a:ext cx="5132564" cy="1448298"/>
+          </a:xfrm>
+          <a:prstGeom prst="rect">
+            <a:avLst/>
+          </a:prstGeom>
+        </p:spPr>
+      </p:pic>
+      <p:sp>
+        <p:nvSpPr>
+          <p:cNvPr id="19" name="TextBox 18">
+            <a:extLst>
+              <a:ext uri="{FF2B5EF4-FFF2-40B4-BE49-F238E27FC236}">
+                <a16:creationId xmlns:a16="http://schemas.microsoft.com/office/drawing/2014/main" id="{21C6AE5F-E412-D9D1-BA87-282802AC0C2E}"/>
+              </a:ext>
+            </a:extLst>
+          </p:cNvPr>
+          <p:cNvSpPr txBox="1"/>
+          <p:nvPr/>
+        </p:nvSpPr>
+        <p:spPr>
+          <a:xfrm>
+            <a:off x="4218657" y="6448595"/>
+            <a:ext cx="951229" cy="338554"/>
+          </a:xfrm>
+          <a:prstGeom prst="rect">
+            <a:avLst/>
+          </a:prstGeom>
+          <a:noFill/>
+        </p:spPr>
+        <p:txBody>
+          <a:bodyPr wrap="square" rtlCol="0">
+            <a:spAutoFit/>
+          </a:bodyPr>
+          <a:lstStyle/>
+          <a:p>
+            <a:pPr algn="ctr"/>
+            <a:r>
+              <a:rPr lang="en-US" sz="1600" dirty="0">
+                <a:latin typeface="Segoe UI" panose="020B0502040204020203" pitchFamily="34" charset="0"/>
+                <a:cs typeface="Segoe UI" panose="020B0502040204020203" pitchFamily="34" charset="0"/>
+              </a:rPr>
+              <a:t>Baseline</a:t>
+            </a:r>
+            <a:endParaRPr lang="en-US" dirty="0">
+              <a:latin typeface="Segoe UI" panose="020B0502040204020203" pitchFamily="34" charset="0"/>
+              <a:cs typeface="Segoe UI" panose="020B0502040204020203" pitchFamily="34" charset="0"/>
+            </a:endParaRPr>
+          </a:p>
+        </p:txBody>
+      </p:sp>
+      <p:sp>
+        <p:nvSpPr>
+          <p:cNvPr id="20" name="TextBox 19">
+            <a:extLst>
+              <a:ext uri="{FF2B5EF4-FFF2-40B4-BE49-F238E27FC236}">
+                <a16:creationId xmlns:a16="http://schemas.microsoft.com/office/drawing/2014/main" id="{81178A97-7400-7D29-1E61-2ABC3D1A78D0}"/>
+              </a:ext>
+            </a:extLst>
+          </p:cNvPr>
+          <p:cNvSpPr txBox="1"/>
+          <p:nvPr/>
+        </p:nvSpPr>
+        <p:spPr>
+          <a:xfrm>
+            <a:off x="6184287" y="6448595"/>
+            <a:ext cx="1071546" cy="338554"/>
+          </a:xfrm>
+          <a:prstGeom prst="rect">
+            <a:avLst/>
+          </a:prstGeom>
+          <a:noFill/>
+        </p:spPr>
+        <p:txBody>
+          <a:bodyPr wrap="square" rtlCol="0">
+            <a:spAutoFit/>
+          </a:bodyPr>
+          <a:lstStyle/>
+          <a:p>
+            <a:pPr algn="ctr"/>
+            <a:r>
+              <a:rPr lang="en-US" sz="1600" dirty="0">
+                <a:latin typeface="Segoe UI" panose="020B0502040204020203" pitchFamily="34" charset="0"/>
+                <a:cs typeface="Segoe UI" panose="020B0502040204020203" pitchFamily="34" charset="0"/>
+              </a:rPr>
+              <a:t>Post-HFS</a:t>
+            </a:r>
+            <a:endParaRPr lang="en-US" dirty="0">
+              <a:latin typeface="Segoe UI" panose="020B0502040204020203" pitchFamily="34" charset="0"/>
+              <a:cs typeface="Segoe UI" panose="020B0502040204020203" pitchFamily="34" charset="0"/>
+            </a:endParaRPr>
+          </a:p>
+        </p:txBody>
+      </p:sp>
+      <p:sp>
+        <p:nvSpPr>
+          <p:cNvPr id="21" name="TextBox 20">
+            <a:extLst>
+              <a:ext uri="{FF2B5EF4-FFF2-40B4-BE49-F238E27FC236}">
+                <a16:creationId xmlns:a16="http://schemas.microsoft.com/office/drawing/2014/main" id="{BA15E6DA-046A-1350-2D59-07A0A5115FCE}"/>
+              </a:ext>
+            </a:extLst>
+          </p:cNvPr>
+          <p:cNvSpPr txBox="1"/>
+          <p:nvPr/>
+        </p:nvSpPr>
+        <p:spPr>
+          <a:xfrm>
+            <a:off x="2523718" y="7884238"/>
+            <a:ext cx="442301" cy="369012"/>
+          </a:xfrm>
+          <a:prstGeom prst="rect">
+            <a:avLst/>
+          </a:prstGeom>
+          <a:noFill/>
+        </p:spPr>
+        <p:txBody>
+          <a:bodyPr wrap="square" rtlCol="0">
+            <a:spAutoFit/>
+          </a:bodyPr>
+          <a:lstStyle/>
+          <a:p>
+            <a:r>
+              <a:rPr lang="en-US" sz="1798" b="1" dirty="0">
+                <a:latin typeface="Arial" panose="020B0604020202020204" pitchFamily="34" charset="0"/>
+                <a:cs typeface="Arial" panose="020B0604020202020204" pitchFamily="34" charset="0"/>
+              </a:rPr>
+              <a:t>C.</a:t>
+            </a:r>
+          </a:p>
+        </p:txBody>
+      </p:sp>
+    </p:spTree>
+    <p:extLst>
+      <p:ext uri="{BB962C8B-B14F-4D97-AF65-F5344CB8AC3E}">
+        <p14:creationId xmlns:p14="http://schemas.microsoft.com/office/powerpoint/2010/main" val="2874536972"/>
       </p:ext>
     </p:extLst>
   </p:cSld>

</xml_diff>